<commit_message>
Add Honduras year-by-year table: productivity, fertiliser, rust, varieties, finance, lempira
New workbook and 6-slide deck with year-on-year changes 2005-2026:
yield per bearing hectare and per tree, FAOSTAT nitrogen and urea
imports, urea and coffee prices in lempiras (BCH daily rate), every
rust figure found, variety adoption, Bono Cafetalero and financing
programmes. FAOSTAT fertiliser use now runs to 2024 in the yield-driver
work (2022 imputed by FAO); stale 'stops in 2022' text corrected.

Co-Authored-By: Claude Opus 5.5 <noreply@anthropic.com>
Claude-Session: https://claude.ai/code/session_01GCSUFXh2mYdWNgg7VCeE1G
</commit_message>
<xml_diff>
--- a/research/honduras/slides/Honduras_yield_drivers_forecast.pptx
+++ b/research/honduras/slides/Honduras_yield_drivers_forecast.pptx
@@ -1916,9 +1916,9 @@
           <c:invertIfNegative val="0"/>
           <c:cat>
             <c:strRef>
-              <c:f>Sheet1!$A$2:$A$19</c:f>
+              <c:f>Sheet1!$A$2:$A$21</c:f>
               <c:strCache>
-                <c:ptCount val="18"/>
+                <c:ptCount val="20"/>
                 <c:pt idx="0">
                   <c:v>05/06</c:v>
                 </c:pt>
@@ -1972,16 +1972,22 @@
                 </c:pt>
                 <c:pt idx="17">
                   <c:v>22/23</c:v>
+                </c:pt>
+                <c:pt idx="18">
+                  <c:v>23/24</c:v>
+                </c:pt>
+                <c:pt idx="19">
+                  <c:v>24/25</c:v>
                 </c:pt>
               </c:strCache>
             </c:strRef>
           </c:cat>
           <c:val>
             <c:numRef>
-              <c:f>Sheet1!$B$2:$B$19</c:f>
+              <c:f>Sheet1!$B$2:$B$21</c:f>
               <c:numCache>
                 <c:formatCode>General</c:formatCode>
-                <c:ptCount val="18"/>
+                <c:ptCount val="20"/>
                 <c:pt idx="0">
                   <c:v>59.24305819703308</c:v>
                 </c:pt>
@@ -2035,6 +2041,12 @@
                 </c:pt>
                 <c:pt idx="17">
                   <c:v>-0.0028607392150159505</c:v>
+                </c:pt>
+                <c:pt idx="18">
+                  <c:v>-0.4176798741238774</c:v>
+                </c:pt>
+                <c:pt idx="19">
+                  <c:v>2.3011290183573285</c:v>
                 </c:pt>
               </c:numCache>
             </c:numRef>
@@ -2062,9 +2074,9 @@
           <c:invertIfNegative val="0"/>
           <c:cat>
             <c:strRef>
-              <c:f>Sheet1!$A$2:$A$19</c:f>
+              <c:f>Sheet1!$A$2:$A$21</c:f>
               <c:strCache>
-                <c:ptCount val="18"/>
+                <c:ptCount val="20"/>
                 <c:pt idx="0">
                   <c:v>05/06</c:v>
                 </c:pt>
@@ -2118,16 +2130,22 @@
                 </c:pt>
                 <c:pt idx="17">
                   <c:v>22/23</c:v>
+                </c:pt>
+                <c:pt idx="18">
+                  <c:v>23/24</c:v>
+                </c:pt>
+                <c:pt idx="19">
+                  <c:v>24/25</c:v>
                 </c:pt>
               </c:strCache>
             </c:strRef>
           </c:cat>
           <c:val>
             <c:numRef>
-              <c:f>Sheet1!$C$2:$C$19</c:f>
+              <c:f>Sheet1!$C$2:$C$21</c:f>
               <c:numCache>
                 <c:formatCode>General</c:formatCode>
-                <c:ptCount val="18"/>
+                <c:ptCount val="20"/>
                 <c:pt idx="0">
                   <c:v>24.427184466019412</c:v>
                 </c:pt>
@@ -2181,6 +2199,12 @@
                 </c:pt>
                 <c:pt idx="17">
                   <c:v>18.75</c:v>
+                </c:pt>
+                <c:pt idx="18">
+                  <c:v>-11.403508771929827</c:v>
+                </c:pt>
+                <c:pt idx="19">
+                  <c:v>2.970297029702973</c:v>
                 </c:pt>
               </c:numCache>
             </c:numRef>
@@ -4790,7 +4814,7 @@
                 <a:latin typeface="Arial"/>
                 <a:cs typeface="Arial"/>
               </a:rPr>
-              <a:t>0,01</a:t>
+              <a:t>0,00</a:t>
             </a:r>
           </a:p>
         </p:txBody>
@@ -5672,7 +5696,7 @@
                 <a:latin typeface="Arial"/>
                 <a:cs typeface="Arial"/>
               </a:rPr>
-              <a:t>0,25</a:t>
+              <a:t>0,26</a:t>
             </a:r>
           </a:p>
         </p:txBody>
@@ -5917,7 +5941,7 @@
                 <a:latin typeface="Arial"/>
                 <a:cs typeface="Arial"/>
               </a:rPr>
-              <a:t>0,030</a:t>
+              <a:t>0,027</a:t>
             </a:r>
           </a:p>
         </p:txBody>
@@ -5966,7 +5990,7 @@
                 <a:latin typeface="Arial"/>
                 <a:cs typeface="Arial"/>
               </a:rPr>
-              <a:t>0,30</a:t>
+              <a:t>0,27</a:t>
             </a:r>
           </a:p>
         </p:txBody>
@@ -6211,7 +6235,7 @@
                 <a:latin typeface="Arial"/>
                 <a:cs typeface="Arial"/>
               </a:rPr>
-              <a:t>0,036</a:t>
+              <a:t>0,034</a:t>
             </a:r>
           </a:p>
         </p:txBody>
@@ -6260,7 +6284,7 @@
                 <a:latin typeface="Arial"/>
                 <a:cs typeface="Arial"/>
               </a:rPr>
-              <a:t>0,32</a:t>
+              <a:t>0,31</a:t>
             </a:r>
           </a:p>
         </p:txBody>
@@ -6505,7 +6529,7 @@
                 <a:latin typeface="Arial"/>
                 <a:cs typeface="Arial"/>
               </a:rPr>
-              <a:t>0,200</a:t>
+              <a:t>0,201</a:t>
             </a:r>
           </a:p>
         </p:txBody>
@@ -6652,7 +6676,7 @@
                 <a:latin typeface="Arial"/>
                 <a:cs typeface="Arial"/>
               </a:rPr>
-              <a:t>Rain Jun–Oct (fruit fill)</a:t>
+              <a:t>Rain Apr–May (flowering, fruit set)</a:t>
             </a:r>
           </a:p>
         </p:txBody>
@@ -6750,7 +6774,7 @@
                 <a:latin typeface="Arial"/>
                 <a:cs typeface="Arial"/>
               </a:rPr>
-              <a:t>0,10</a:t>
+              <a:t>−0,10</a:t>
             </a:r>
           </a:p>
         </p:txBody>
@@ -6799,7 +6823,7 @@
                 <a:latin typeface="Arial"/>
                 <a:cs typeface="Arial"/>
               </a:rPr>
-              <a:t>0,507</a:t>
+              <a:t>0,509</a:t>
             </a:r>
           </a:p>
         </p:txBody>
@@ -6946,7 +6970,7 @@
                 <a:latin typeface="Arial"/>
                 <a:cs typeface="Arial"/>
               </a:rPr>
-              <a:t>Rain Apr–May (flowering, fruit set)</a:t>
+              <a:t>Rain Jun–Oct (fruit fill)</a:t>
             </a:r>
           </a:p>
         </p:txBody>
@@ -7044,7 +7068,7 @@
                 <a:latin typeface="Arial"/>
                 <a:cs typeface="Arial"/>
               </a:rPr>
-              <a:t>−0,10</a:t>
+              <a:t>0,10</a:t>
             </a:r>
           </a:p>
         </p:txBody>
@@ -7093,7 +7117,7 @@
                 <a:latin typeface="Arial"/>
                 <a:cs typeface="Arial"/>
               </a:rPr>
-              <a:t>0,509</a:t>
+              <a:t>0,517</a:t>
             </a:r>
           </a:p>
         </p:txBody>
@@ -7387,7 +7411,7 @@
                 <a:latin typeface="Arial"/>
                 <a:cs typeface="Arial"/>
               </a:rPr>
-              <a:t>0,628</a:t>
+              <a:t>0,622</a:t>
             </a:r>
           </a:p>
         </p:txBody>
@@ -7681,7 +7705,7 @@
                 <a:latin typeface="Arial"/>
                 <a:cs typeface="Arial"/>
               </a:rPr>
-              <a:t>0,652</a:t>
+              <a:t>0,644</a:t>
             </a:r>
           </a:p>
         </p:txBody>
@@ -7975,7 +7999,7 @@
                 <a:latin typeface="Arial"/>
                 <a:cs typeface="Arial"/>
               </a:rPr>
-              <a:t>0,859</a:t>
+              <a:t>0,855</a:t>
             </a:r>
           </a:p>
         </p:txBody>
@@ -8269,7 +8293,7 @@
                 <a:latin typeface="Arial"/>
                 <a:cs typeface="Arial"/>
               </a:rPr>
-              <a:t>0,951</a:t>
+              <a:t>0,944</a:t>
             </a:r>
           </a:p>
         </p:txBody>
@@ -8563,7 +8587,7 @@
                 <a:latin typeface="Arial"/>
                 <a:cs typeface="Arial"/>
               </a:rPr>
-              <a:t>0,955</a:t>
+              <a:t>0,958</a:t>
             </a:r>
           </a:p>
         </p:txBody>
@@ -8857,7 +8881,7 @@
                 <a:latin typeface="Arial"/>
                 <a:cs typeface="Arial"/>
               </a:rPr>
-              <a:t>0,003</a:t>
+              <a:t>0,002</a:t>
             </a:r>
           </a:p>
         </p:txBody>
@@ -9399,7 +9423,7 @@
                 <a:latin typeface="Arial"/>
                 <a:cs typeface="Arial"/>
               </a:rPr>
-              <a:t>Tests: research/honduras/yield_drivers/analysis.py and robustness.py. r = Pearson correlation of year-on-year log changes; p = 5 000 random shuffles; Holm = correction for 14 tests. USDA PSD (production, 1 000 60-kg bags, crop year Oct–Sep, July 2026 download); FAOSTAT nitrogen use (all crops, 2004–2022); World Bank Pink Sheet; GPCC rain at 3 coffee towns; NOAA ONI; NASA POWER; ERA5-Land max. temperature at 10 coffee points. Bono: USDA GAIN 2021.</a:t>
+              <a:t>Tests: research/honduras/yield_drivers/analysis.py and robustness.py. r = Pearson correlation of year-on-year log changes; p = 5 000 random shuffles; Holm = correction for 14 tests. USDA PSD (production, 1 000 60-kg bags, crop year Oct–Sep, July 2026 download); FAOSTAT nitrogen use (all crops, 2004–2024); World Bank Pink Sheet; GPCC rain at 3 coffee towns; NOAA ONI; NASA POWER; ERA5-Land max. temperature at 10 coffee points. Bono: USDA GAIN 2021.</a:t>
             </a:r>
           </a:p>
         </p:txBody>
@@ -13630,7 +13654,7 @@
                 <a:latin typeface="Arial"/>
                 <a:cs typeface="Arial"/>
               </a:rPr>
-              <a:t>What moves nitrogen use? (2005–2022)</a:t>
+              <a:t>What moves nitrogen use? (2005–2024)</a:t>
             </a:r>
           </a:p>
         </p:txBody>
@@ -14071,7 +14095,7 @@
                 <a:latin typeface="Arial"/>
                 <a:cs typeface="Arial"/>
               </a:rPr>
-              <a:t>0,791</a:t>
+              <a:t>0,769</a:t>
             </a:r>
           </a:p>
         </p:txBody>
@@ -14218,7 +14242,7 @@
                 <a:latin typeface="Arial"/>
                 <a:cs typeface="Arial"/>
               </a:rPr>
-              <a:t>0,247</a:t>
+              <a:t>0,244</a:t>
             </a:r>
           </a:p>
         </p:txBody>
@@ -14316,7 +14340,7 @@
                 <a:latin typeface="Arial"/>
                 <a:cs typeface="Arial"/>
               </a:rPr>
-              <a:t>0,23</a:t>
+              <a:t>0,18</a:t>
             </a:r>
           </a:p>
         </p:txBody>
@@ -14365,7 +14389,7 @@
                 <a:latin typeface="Arial"/>
                 <a:cs typeface="Arial"/>
               </a:rPr>
-              <a:t>0,369</a:t>
+              <a:t>0,451</a:t>
             </a:r>
           </a:p>
         </p:txBody>
@@ -14463,7 +14487,7 @@
                 <a:latin typeface="Arial"/>
                 <a:cs typeface="Arial"/>
               </a:rPr>
-              <a:t>−0,03</a:t>
+              <a:t>0,02</a:t>
             </a:r>
           </a:p>
         </p:txBody>
@@ -14512,7 +14536,7 @@
                 <a:latin typeface="Arial"/>
                 <a:cs typeface="Arial"/>
               </a:rPr>
-              <a:t>0,915</a:t>
+              <a:t>0,950</a:t>
             </a:r>
           </a:p>
         </p:txBody>
@@ -14659,7 +14683,7 @@
                 <a:latin typeface="Arial"/>
                 <a:cs typeface="Arial"/>
               </a:rPr>
-              <a:t>0,057</a:t>
+              <a:t>0,055</a:t>
             </a:r>
           </a:p>
         </p:txBody>
@@ -14750,7 +14774,7 @@
                 <a:latin typeface="Arial"/>
                 <a:cs typeface="Arial"/>
               </a:rPr>
-              <a:t>FAOSTAT stops in 2022: for 2026 watch fertiliser imports and the urea price (+33 % in Jan–Aug 2026).</a:t>
+              <a:t>FAOSTAT runs to 2024 (2022 imputed): for 2025–26 watch fertiliser imports and the urea price (+33 % in Jan–Aug 2026).</a:t>
             </a:r>
           </a:p>
         </p:txBody>
@@ -17668,7 +17692,7 @@
                 <a:latin typeface="Arial"/>
                 <a:cs typeface="Arial"/>
               </a:rPr>
-              <a:t>0,51</a:t>
+              <a:t>0,52</a:t>
             </a:r>
           </a:p>
         </p:txBody>
@@ -17962,7 +17986,7 @@
                 <a:latin typeface="Arial"/>
                 <a:cs typeface="Arial"/>
               </a:rPr>
-              <a:t>0,95</a:t>
+              <a:t>0,94</a:t>
             </a:r>
           </a:p>
         </p:txBody>
@@ -18109,7 +18133,7 @@
                 <a:latin typeface="Arial"/>
                 <a:cs typeface="Arial"/>
               </a:rPr>
-              <a:t>0,285</a:t>
+              <a:t>0,303</a:t>
             </a:r>
           </a:p>
         </p:txBody>
@@ -18256,7 +18280,7 @@
                 <a:latin typeface="Arial"/>
                 <a:cs typeface="Arial"/>
               </a:rPr>
-              <a:t>0,053</a:t>
+              <a:t>0,048</a:t>
             </a:r>
           </a:p>
         </p:txBody>
@@ -18403,7 +18427,7 @@
                 <a:latin typeface="Arial"/>
                 <a:cs typeface="Arial"/>
               </a:rPr>
-              <a:t>0,003</a:t>
+              <a:t>0,002</a:t>
             </a:r>
           </a:p>
         </p:txBody>
@@ -18550,7 +18574,7 @@
                 <a:latin typeface="Arial"/>
                 <a:cs typeface="Arial"/>
               </a:rPr>
-              <a:t>0,006</a:t>
+              <a:t>0,009</a:t>
             </a:r>
           </a:p>
         </p:txBody>

</xml_diff>